<commit_message>
fix(xlsx, ods, pptx, odp): sixth review fixes for links
- Every link a cell cannot hold is reported, beside the one it does (a bookmark or an address too
  long after a written link went unreported).
- Places are found by an index of the sheets' names: many links over many sheets took time in their
  product.
- A range (#Sheet!A1:C3, ODF's #Sheet.A1:Sheet.C3) is written whole.
- An address's length is measured as it is written (encoded).
- A link relative to the file is written, as DOCX output writes it; a script's is not.
</commit_message>
<xml_diff>
--- a/test/generator/baseline/gen.epub.to.pptx.pptx
+++ b/test/generator/baseline/gen.epub.to.pptx.pptx
@@ -7664,7 +7664,9 @@
               <a:t>Footnotes</a:t>
             </a:r>
             <a:r>
-              <a:rPr lang="en-US" sz="1800" baseline="30000" dirty="0"/>
+              <a:rPr lang="en-US" sz="1800" baseline="30000" dirty="0">
+                <a:hlinkClick r:id="rId2"/>
+              </a:rPr>
               <a:t>1</a:t>
             </a:r>
             <a:r>
@@ -7672,7 +7674,9 @@
               <a:t> and endnotes</a:t>
             </a:r>
             <a:r>
-              <a:rPr lang="en-US" sz="1800" baseline="30000" dirty="0"/>
+              <a:rPr lang="en-US" sz="1800" baseline="30000" dirty="0">
+                <a:hlinkClick r:id="rId3"/>
+              </a:rPr>
               <a:t>2</a:t>
             </a:r>
             <a:r>
@@ -7894,7 +7898,9 @@
               <a:t>. Then we have a link that points back to the section on </a:t>
             </a:r>
             <a:r>
-              <a:rPr lang="en-US" sz="1800" dirty="0"/>
+              <a:rPr lang="en-US" sz="1800" dirty="0">
+                <a:hlinkClick r:id="rId3"/>
+              </a:rPr>
               <a:t>paragraph level formatting</a:t>
             </a:r>
             <a:r>
@@ -8005,15 +8011,21 @@
               <a:buNone/>
             </a:pPr>
             <a:r>
-              <a:rPr lang="en-US" sz="1800" dirty="0"/>
+              <a:rPr lang="en-US" sz="1800" dirty="0">
+                <a:hlinkClick r:id="rId2"/>
+              </a:rPr>
               <a:t>Demonstration of DOCX support in calibre</a:t>
             </a:r>
             <a:r>
-              <a:rPr lang="en-US" sz="1800" dirty="0"/>
+              <a:rPr lang="en-US" sz="1800" dirty="0">
+                <a:hlinkClick r:id="rId3"/>
+              </a:rPr>
               <a:t> </a:t>
             </a:r>
             <a:r>
-              <a:rPr lang="en-US" sz="1800" dirty="0"/>
+              <a:rPr lang="en-US" sz="1800" dirty="0">
+                <a:hlinkClick r:id="rId4"/>
+              </a:rPr>
               <a:t>1</a:t>
             </a:r>
             <a:endParaRPr lang="en-US" sz="1800" dirty="0"/>
@@ -8023,15 +8035,21 @@
               <a:buNone/>
             </a:pPr>
             <a:r>
-              <a:rPr lang="en-US" sz="1800" dirty="0"/>
+              <a:rPr lang="en-US" sz="1800" dirty="0">
+                <a:hlinkClick r:id="rId5"/>
+              </a:rPr>
               <a:t>Text Formatting</a:t>
             </a:r>
             <a:r>
-              <a:rPr lang="en-US" sz="1800" dirty="0"/>
+              <a:rPr lang="en-US" sz="1800" dirty="0">
+                <a:hlinkClick r:id="rId6"/>
+              </a:rPr>
               <a:t> </a:t>
             </a:r>
             <a:r>
-              <a:rPr lang="en-US" sz="1800" dirty="0"/>
+              <a:rPr lang="en-US" sz="1800" dirty="0">
+                <a:hlinkClick r:id="rId7"/>
+              </a:rPr>
               <a:t>1</a:t>
             </a:r>
             <a:endParaRPr lang="en-US" sz="1800" dirty="0"/>
@@ -8041,15 +8059,21 @@
               <a:buNone/>
             </a:pPr>
             <a:r>
-              <a:rPr lang="en-US" sz="1800" dirty="0"/>
+              <a:rPr lang="en-US" sz="1800" dirty="0">
+                <a:hlinkClick r:id="rId8"/>
+              </a:rPr>
               <a:t>Inline formatting</a:t>
             </a:r>
             <a:r>
-              <a:rPr lang="en-US" sz="1800" dirty="0"/>
+              <a:rPr lang="en-US" sz="1800" dirty="0">
+                <a:hlinkClick r:id="rId9"/>
+              </a:rPr>
               <a:t> </a:t>
             </a:r>
             <a:r>
-              <a:rPr lang="en-US" sz="1800" dirty="0"/>
+              <a:rPr lang="en-US" sz="1800" dirty="0">
+                <a:hlinkClick r:id="rId10"/>
+              </a:rPr>
               <a:t>2</a:t>
             </a:r>
             <a:endParaRPr lang="en-US" sz="1800" dirty="0"/>
@@ -8059,15 +8083,21 @@
               <a:buNone/>
             </a:pPr>
             <a:r>
-              <a:rPr lang="en-US" sz="1800" dirty="0"/>
+              <a:rPr lang="en-US" sz="1800" dirty="0">
+                <a:hlinkClick r:id="rId11"/>
+              </a:rPr>
               <a:t>Fun with fonts</a:t>
             </a:r>
             <a:r>
-              <a:rPr lang="en-US" sz="1800" dirty="0"/>
+              <a:rPr lang="en-US" sz="1800" dirty="0">
+                <a:hlinkClick r:id="rId12"/>
+              </a:rPr>
               <a:t> </a:t>
             </a:r>
             <a:r>
-              <a:rPr lang="en-US" sz="1800" dirty="0"/>
+              <a:rPr lang="en-US" sz="1800" dirty="0">
+                <a:hlinkClick r:id="rId13"/>
+              </a:rPr>
               <a:t>2</a:t>
             </a:r>
             <a:endParaRPr lang="en-US" sz="1800" dirty="0"/>
@@ -8077,15 +8107,21 @@
               <a:buNone/>
             </a:pPr>
             <a:r>
-              <a:rPr lang="en-US" sz="1800" dirty="0"/>
+              <a:rPr lang="en-US" sz="1800" dirty="0">
+                <a:hlinkClick r:id="rId14"/>
+              </a:rPr>
               <a:t>Paragraph level formatting</a:t>
             </a:r>
             <a:r>
-              <a:rPr lang="en-US" sz="1800" dirty="0"/>
+              <a:rPr lang="en-US" sz="1800" dirty="0">
+                <a:hlinkClick r:id="rId15"/>
+              </a:rPr>
               <a:t> </a:t>
             </a:r>
             <a:r>
-              <a:rPr lang="en-US" sz="1800" dirty="0"/>
+              <a:rPr lang="en-US" sz="1800" dirty="0">
+                <a:hlinkClick r:id="rId16"/>
+              </a:rPr>
               <a:t>2</a:t>
             </a:r>
             <a:endParaRPr lang="en-US" sz="1800" dirty="0"/>
@@ -8095,15 +8131,21 @@
               <a:buNone/>
             </a:pPr>
             <a:r>
-              <a:rPr lang="en-US" sz="1800" dirty="0"/>
+              <a:rPr lang="en-US" sz="1800" dirty="0">
+                <a:hlinkClick r:id="rId17"/>
+              </a:rPr>
               <a:t>Tables</a:t>
             </a:r>
             <a:r>
-              <a:rPr lang="en-US" sz="1800" dirty="0"/>
+              <a:rPr lang="en-US" sz="1800" dirty="0">
+                <a:hlinkClick r:id="rId18"/>
+              </a:rPr>
               <a:t> </a:t>
             </a:r>
             <a:r>
-              <a:rPr lang="en-US" sz="1800" dirty="0"/>
+              <a:rPr lang="en-US" sz="1800" dirty="0">
+                <a:hlinkClick r:id="rId19"/>
+              </a:rPr>
               <a:t>2</a:t>
             </a:r>
             <a:endParaRPr lang="en-US" sz="1800" dirty="0"/>
@@ -8536,15 +8578,21 @@
               <a:buNone/>
             </a:pPr>
             <a:r>
-              <a:rPr lang="en-US" sz="1800" dirty="0"/>
+              <a:rPr lang="en-US" sz="1800" dirty="0">
+                <a:hlinkClick r:id="rId2"/>
+              </a:rPr>
               <a:t>Images</a:t>
             </a:r>
             <a:r>
-              <a:rPr lang="en-US" sz="1800" dirty="0"/>
+              <a:rPr lang="en-US" sz="1800" dirty="0">
+                <a:hlinkClick r:id="rId3"/>
+              </a:rPr>
               <a:t> </a:t>
             </a:r>
             <a:r>
-              <a:rPr lang="en-US" sz="1800" dirty="0"/>
+              <a:rPr lang="en-US" sz="1800" dirty="0">
+                <a:hlinkClick r:id="rId4"/>
+              </a:rPr>
               <a:t>6</a:t>
             </a:r>
             <a:endParaRPr lang="en-US" sz="1800" dirty="0"/>
@@ -8554,15 +8602,21 @@
               <a:buNone/>
             </a:pPr>
             <a:r>
-              <a:rPr lang="en-US" sz="1800" dirty="0"/>
+              <a:rPr lang="en-US" sz="1800" dirty="0">
+                <a:hlinkClick r:id="rId5"/>
+              </a:rPr>
               <a:t>Lists</a:t>
             </a:r>
             <a:r>
-              <a:rPr lang="en-US" sz="1800" dirty="0"/>
+              <a:rPr lang="en-US" sz="1800" dirty="0">
+                <a:hlinkClick r:id="rId6"/>
+              </a:rPr>
               <a:t> </a:t>
             </a:r>
             <a:r>
-              <a:rPr lang="en-US" sz="1800" dirty="0"/>
+              <a:rPr lang="en-US" sz="1800" dirty="0">
+                <a:hlinkClick r:id="rId7"/>
+              </a:rPr>
               <a:t>7</a:t>
             </a:r>
             <a:endParaRPr lang="en-US" sz="1800" dirty="0"/>
@@ -8572,15 +8626,21 @@
               <a:buNone/>
             </a:pPr>
             <a:r>
-              <a:rPr lang="en-US" sz="1800" dirty="0"/>
+              <a:rPr lang="en-US" sz="1800" dirty="0">
+                <a:hlinkClick r:id="rId8"/>
+              </a:rPr>
               <a:t>Bulleted List</a:t>
             </a:r>
             <a:r>
-              <a:rPr lang="en-US" sz="1800" dirty="0"/>
+              <a:rPr lang="en-US" sz="1800" dirty="0">
+                <a:hlinkClick r:id="rId9"/>
+              </a:rPr>
               <a:t> </a:t>
             </a:r>
             <a:r>
-              <a:rPr lang="en-US" sz="1800" dirty="0"/>
+              <a:rPr lang="en-US" sz="1800" dirty="0">
+                <a:hlinkClick r:id="rId10"/>
+              </a:rPr>
               <a:t>8</a:t>
             </a:r>
             <a:endParaRPr lang="en-US" sz="1800" dirty="0"/>
@@ -8590,15 +8650,21 @@
               <a:buNone/>
             </a:pPr>
             <a:r>
-              <a:rPr lang="en-US" sz="1800" dirty="0"/>
+              <a:rPr lang="en-US" sz="1800" dirty="0">
+                <a:hlinkClick r:id="rId11"/>
+              </a:rPr>
               <a:t>Numbered List</a:t>
             </a:r>
             <a:r>
-              <a:rPr lang="en-US" sz="1800" dirty="0"/>
+              <a:rPr lang="en-US" sz="1800" dirty="0">
+                <a:hlinkClick r:id="rId12"/>
+              </a:rPr>
               <a:t> </a:t>
             </a:r>
             <a:r>
-              <a:rPr lang="en-US" sz="1800" dirty="0"/>
+              <a:rPr lang="en-US" sz="1800" dirty="0">
+                <a:hlinkClick r:id="rId13"/>
+              </a:rPr>
               <a:t>8</a:t>
             </a:r>
             <a:endParaRPr lang="en-US" sz="1800" dirty="0"/>
@@ -8608,15 +8674,21 @@
               <a:buNone/>
             </a:pPr>
             <a:r>
-              <a:rPr lang="en-US" sz="1800" dirty="0"/>
+              <a:rPr lang="en-US" sz="1800" dirty="0">
+                <a:hlinkClick r:id="rId14"/>
+              </a:rPr>
               <a:t>Multi-level Lists</a:t>
             </a:r>
             <a:r>
-              <a:rPr lang="en-US" sz="1800" dirty="0"/>
+              <a:rPr lang="en-US" sz="1800" dirty="0">
+                <a:hlinkClick r:id="rId15"/>
+              </a:rPr>
               <a:t> </a:t>
             </a:r>
             <a:r>
-              <a:rPr lang="en-US" sz="1800" dirty="0"/>
+              <a:rPr lang="en-US" sz="1800" dirty="0">
+                <a:hlinkClick r:id="rId16"/>
+              </a:rPr>
               <a:t>8</a:t>
             </a:r>
             <a:endParaRPr lang="en-US" sz="1800" dirty="0"/>
@@ -8626,15 +8698,21 @@
               <a:buNone/>
             </a:pPr>
             <a:r>
-              <a:rPr lang="en-US" sz="1800" dirty="0"/>
+              <a:rPr lang="en-US" sz="1800" dirty="0">
+                <a:hlinkClick r:id="rId17"/>
+              </a:rPr>
               <a:t>Continued Lists</a:t>
             </a:r>
             <a:r>
-              <a:rPr lang="en-US" sz="1800" dirty="0"/>
+              <a:rPr lang="en-US" sz="1800" dirty="0">
+                <a:hlinkClick r:id="rId18"/>
+              </a:rPr>
               <a:t> </a:t>
             </a:r>
             <a:r>
-              <a:rPr lang="en-US" sz="1800" dirty="0"/>
+              <a:rPr lang="en-US" sz="1800" dirty="0">
+                <a:hlinkClick r:id="rId19"/>
+              </a:rPr>
               <a:t>8</a:t>
             </a:r>
             <a:endParaRPr lang="en-US" sz="1800" dirty="0"/>
@@ -9908,7 +9986,9 @@
               <a:t>[</a:t>
             </a:r>
             <a:r>
-              <a:rPr lang="en-US" sz="1800" dirty="0"/>
+              <a:rPr lang="en-US" sz="1800" dirty="0">
+                <a:hlinkClick r:id="rId2"/>
+              </a:rPr>
               <a:t>←1</a:t>
             </a:r>
             <a:r>
@@ -9936,7 +10016,9 @@
               <a:t>[</a:t>
             </a:r>
             <a:r>
-              <a:rPr lang="en-US" sz="1800" dirty="0"/>
+              <a:rPr lang="en-US" sz="1800" dirty="0">
+                <a:hlinkClick r:id="rId3"/>
+              </a:rPr>
               <a:t>←2</a:t>
             </a:r>
             <a:r>

</xml_diff>